<commit_message>
slides(course): regen ch03 deck for claude-tool-use-from-zero post G0-fix [KOEA-7962]
Source chapter revised 2026-06-12 (correct @modelcontextprotocol/sdk imports,
server.tool registration, path-escape guard, controlled-error pattern).
Overwrites stale 2026-05-26 deck with fresh 6-slide deck from updated chapter.
audio_produced=0 (OpenAI TTS quota exceeded per KOEA-7801 — not blocking).

Co-Authored-By: Claude Sonnet 4.6 <noreply@anthropic.com>
</commit_message>
<xml_diff>
--- a/vault/courses/claude-tool-use-from-zero/ch03-slides.pptx
+++ b/vault/courses/claude-tool-use-from-zero/ch03-slides.pptx
@@ -11,7 +11,6 @@
     <p:sldId id="259" r:id="rId10"/>
     <p:sldId id="260" r:id="rId11"/>
     <p:sldId id="261" r:id="rId12"/>
-    <p:sldId id="262" r:id="rId13"/>
   </p:sldIdLst>
   <p:sldSz cx="12191695" cy="6858000" type="screen4x3"/>
   <p:notesSz cx="6858000" cy="9144000"/>
@@ -3225,7 +3224,7 @@
                   <a:srgbClr val="FFFFFF"/>
                 </a:solidFill>
               </a:rPr>
-              <a:t>Prerequisites check</a:t>
+              <a:t>What the server will do</a:t>
             </a:r>
           </a:p>
         </p:txBody>
@@ -3302,7 +3301,7 @@
                   <a:srgbClr val="FFFFFF"/>
                 </a:solidFill>
               </a:rPr>
-              <a:t>  You should have completed the MCP classification exercise from Chapter 2. You should also be comfortable running a Node.js script locally. I</a:t>
+              <a:t>  The server exposes one tool-use capability:</a:t>
             </a:r>
           </a:p>
         </p:txBody>
@@ -3396,7 +3395,7 @@
                   <a:srgbClr val="FFFFFF"/>
                 </a:solidFill>
               </a:rPr>
-              <a:t>What the server will do</a:t>
+              <a:t>Controlled errors</a:t>
             </a:r>
           </a:p>
         </p:txBody>
@@ -3453,7 +3452,7 @@
         <p:spPr>
           <a:xfrm>
             <a:off x="731520" y="1600200"/>
-            <a:ext cx="10698480" cy="960120"/>
+            <a:ext cx="10698480" cy="777240"/>
           </a:xfrm>
           <a:prstGeom prst="rect">
             <a:avLst/>
@@ -3468,12 +3467,12 @@
           <a:p>
             <a:pPr algn="l"/>
             <a:r>
-              <a:rPr sz="1700" b="0">
+              <a:rPr sz="1500" b="0">
                 <a:solidFill>
                   <a:srgbClr val="FFFFFF"/>
                 </a:solidFill>
               </a:rPr>
-              <a:t>  The server exposes one tool:</a:t>
+              <a:t>  For this chapter, use three predictable errors:</a:t>
             </a:r>
           </a:p>
         </p:txBody>
@@ -3486,8 +3485,8 @@
         </p:nvSpPr>
         <p:spPr>
           <a:xfrm>
-            <a:off x="731520" y="2651760"/>
-            <a:ext cx="10698480" cy="960120"/>
+            <a:off x="731520" y="2468880"/>
+            <a:ext cx="10698480" cy="777240"/>
           </a:xfrm>
           <a:prstGeom prst="rect">
             <a:avLst/>
@@ -3502,12 +3501,12 @@
           <a:p>
             <a:pPr algn="l"/>
             <a:r>
-              <a:rPr sz="1700" b="0">
+              <a:rPr sz="1500" b="0">
                 <a:solidFill>
                   <a:srgbClr val="FFFFFF"/>
                 </a:solidFill>
               </a:rPr>
-              <a:t>  list_project_files(root_label, relative_path)</a:t>
+              <a:t>  Unknown root label.</a:t>
             </a:r>
           </a:p>
         </p:txBody>
@@ -3520,8 +3519,8 @@
         </p:nvSpPr>
         <p:spPr>
           <a:xfrm>
-            <a:off x="731520" y="3703320"/>
-            <a:ext cx="10698480" cy="960120"/>
+            <a:off x="731520" y="3337560"/>
+            <a:ext cx="10698480" cy="777240"/>
           </a:xfrm>
           <a:prstGeom prst="rect">
             <a:avLst/>
@@ -3536,12 +3535,12 @@
           <a:p>
             <a:pPr algn="l"/>
             <a:r>
-              <a:rPr sz="1700" b="0">
+              <a:rPr sz="1500" b="0">
                 <a:solidFill>
                   <a:srgbClr val="FFFFFF"/>
                 </a:solidFill>
               </a:rPr>
-              <a:t>  It lists files under a pre-approved project root. The user can ask Claude to inspect project structure, but the server will not allow arbitr</a:t>
+              <a:t>  Path escapes approved root.</a:t>
             </a:r>
           </a:p>
         </p:txBody>
@@ -3554,8 +3553,8 @@
         </p:nvSpPr>
         <p:spPr>
           <a:xfrm>
-            <a:off x="731520" y="4754880"/>
-            <a:ext cx="10698480" cy="960120"/>
+            <a:off x="731520" y="4206240"/>
+            <a:ext cx="10698480" cy="777240"/>
           </a:xfrm>
           <a:prstGeom prst="rect">
             <a:avLst/>
@@ -3570,12 +3569,12 @@
           <a:p>
             <a:pPr algn="l"/>
             <a:r>
-              <a:rPr sz="1700" b="0">
+              <a:rPr sz="1500" b="0">
                 <a:solidFill>
                   <a:srgbClr val="FFFFFF"/>
                 </a:solidFill>
               </a:rPr>
-              <a:t>  This is the key production lesson: the model should not decide the security boundary. The server decides the boundary, then offers Claude a </a:t>
+              <a:t>  Path does not exist or is not readable.</a:t>
             </a:r>
           </a:p>
         </p:txBody>
@@ -3583,6 +3582,40 @@
       <p:sp>
         <p:nvSpPr>
           <p:cNvPr id="8" name="TextBox 7"/>
+          <p:cNvSpPr txBox="1"/>
+          <p:nvPr/>
+        </p:nvSpPr>
+        <p:spPr>
+          <a:xfrm>
+            <a:off x="731520" y="5074920"/>
+            <a:ext cx="10698480" cy="777240"/>
+          </a:xfrm>
+          <a:prstGeom prst="rect">
+            <a:avLst/>
+          </a:prstGeom>
+          <a:noFill/>
+        </p:spPr>
+        <p:txBody>
+          <a:bodyPr wrap="square">
+            <a:spAutoFit/>
+          </a:bodyPr>
+          <a:lstStyle/>
+          <a:p>
+            <a:pPr algn="l"/>
+            <a:r>
+              <a:rPr sz="1500" b="0">
+                <a:solidFill>
+                  <a:srgbClr val="FFFFFF"/>
+                </a:solidFill>
+              </a:rPr>
+              <a:t>  In production, log the detailed exception server-side and return the minimal useful error to Claude.</a:t>
+            </a:r>
+          </a:p>
+        </p:txBody>
+      </p:sp>
+      <p:sp>
+        <p:nvSpPr>
+          <p:cNvPr id="9" name="TextBox 8"/>
           <p:cNvSpPr txBox="1"/>
           <p:nvPr/>
         </p:nvSpPr>
@@ -3669,7 +3702,7 @@
                   <a:srgbClr val="FFFFFF"/>
                 </a:solidFill>
               </a:rPr>
-              <a:t>Minimal server shape</a:t>
+              <a:t>Hands-on exercise</a:t>
             </a:r>
           </a:p>
         </p:txBody>
@@ -3726,7 +3759,7 @@
         <p:spPr>
           <a:xfrm>
             <a:off x="731520" y="1600200"/>
-            <a:ext cx="10698480" cy="960120"/>
+            <a:ext cx="10698480" cy="777240"/>
           </a:xfrm>
           <a:prstGeom prst="rect">
             <a:avLst/>
@@ -3741,12 +3774,12 @@
           <a:p>
             <a:pPr algn="l"/>
             <a:r>
-              <a:rPr sz="1700" b="0">
+              <a:rPr sz="1500" b="0">
                 <a:solidFill>
                   <a:srgbClr val="FFFFFF"/>
                 </a:solidFill>
               </a:rPr>
-              <a:t>  An MCP server has identity, registered capabilities, and a transport. The SDK README shows a minimal server that registers a greet tool and </a:t>
+              <a:t>  Create a local MCP server named course-file-browser with one list_project_files tool.</a:t>
             </a:r>
           </a:p>
         </p:txBody>
@@ -3759,8 +3792,8 @@
         </p:nvSpPr>
         <p:spPr>
           <a:xfrm>
-            <a:off x="731520" y="2651760"/>
-            <a:ext cx="10698480" cy="960120"/>
+            <a:off x="731520" y="2468880"/>
+            <a:ext cx="10698480" cy="777240"/>
           </a:xfrm>
           <a:prstGeom prst="rect">
             <a:avLst/>
@@ -3775,12 +3808,12 @@
           <a:p>
             <a:pPr algn="l"/>
             <a:r>
-              <a:rPr sz="1700" b="0">
+              <a:rPr sz="1500" b="0">
                 <a:solidFill>
                   <a:srgbClr val="FFFFFF"/>
                 </a:solidFill>
               </a:rPr>
-              <a:t>  import { McpServer } from "@modelcontextprotocol/server";</a:t>
+              <a:t>  Success criteria:</a:t>
             </a:r>
           </a:p>
         </p:txBody>
@@ -3793,8 +3826,8 @@
         </p:nvSpPr>
         <p:spPr>
           <a:xfrm>
-            <a:off x="731520" y="3703320"/>
-            <a:ext cx="10698480" cy="960120"/>
+            <a:off x="731520" y="3337560"/>
+            <a:ext cx="10698480" cy="777240"/>
           </a:xfrm>
           <a:prstGeom prst="rect">
             <a:avLst/>
@@ -3809,12 +3842,12 @@
           <a:p>
             <a:pPr algn="l"/>
             <a:r>
-              <a:rPr sz="1700" b="0">
+              <a:rPr sz="1500" b="0">
                 <a:solidFill>
                   <a:srgbClr val="FFFFFF"/>
                 </a:solidFill>
               </a:rPr>
-              <a:t>  import { StdioServerTransport } from "@modelcontextprotocol/server/stdio";</a:t>
+              <a:t>  The server starts over stdio.</a:t>
             </a:r>
           </a:p>
         </p:txBody>
@@ -3827,8 +3860,8 @@
         </p:nvSpPr>
         <p:spPr>
           <a:xfrm>
-            <a:off x="731520" y="4754880"/>
-            <a:ext cx="10698480" cy="960120"/>
+            <a:off x="731520" y="4206240"/>
+            <a:ext cx="10698480" cy="777240"/>
           </a:xfrm>
           <a:prstGeom prst="rect">
             <a:avLst/>
@@ -3843,12 +3876,12 @@
           <a:p>
             <a:pPr algn="l"/>
             <a:r>
-              <a:rPr sz="1700" b="0">
+              <a:rPr sz="1500" b="0">
                 <a:solidFill>
                   <a:srgbClr val="FFFFFF"/>
                 </a:solidFill>
               </a:rPr>
-              <a:t>  import * as z from "zod/v4";</a:t>
+              <a:t>  The tool lists files under one approved demo directory.</a:t>
             </a:r>
           </a:p>
         </p:txBody>
@@ -3856,6 +3889,40 @@
       <p:sp>
         <p:nvSpPr>
           <p:cNvPr id="8" name="TextBox 7"/>
+          <p:cNvSpPr txBox="1"/>
+          <p:nvPr/>
+        </p:nvSpPr>
+        <p:spPr>
+          <a:xfrm>
+            <a:off x="731520" y="5074920"/>
+            <a:ext cx="10698480" cy="777240"/>
+          </a:xfrm>
+          <a:prstGeom prst="rect">
+            <a:avLst/>
+          </a:prstGeom>
+          <a:noFill/>
+        </p:spPr>
+        <p:txBody>
+          <a:bodyPr wrap="square">
+            <a:spAutoFit/>
+          </a:bodyPr>
+          <a:lstStyle/>
+          <a:p>
+            <a:pPr algn="l"/>
+            <a:r>
+              <a:rPr sz="1500" b="0">
+                <a:solidFill>
+                  <a:srgbClr val="FFFFFF"/>
+                </a:solidFill>
+              </a:rPr>
+              <a:t>  ../ traversal is rejected.</a:t>
+            </a:r>
+          </a:p>
+        </p:txBody>
+      </p:sp>
+      <p:sp>
+        <p:nvSpPr>
+          <p:cNvPr id="9" name="TextBox 8"/>
           <p:cNvSpPr txBox="1"/>
           <p:nvPr/>
         </p:nvSpPr>
@@ -3942,7 +4009,7 @@
                   <a:srgbClr val="FFFFFF"/>
                 </a:solidFill>
               </a:rPr>
-              <a:t>Why this is safer than `read_file(path)`</a:t>
+              <a:t>What's next</a:t>
             </a:r>
           </a:p>
         </p:txBody>
@@ -4019,7 +4086,7 @@
                   <a:srgbClr val="FFFFFF"/>
                 </a:solidFill>
               </a:rPr>
-              <a:t>  A raw read_file(path) tool looks convenient. It is also an invitation to leak secrets. The model might request .env, SSH keys, browser profi</a:t>
+              <a:t>  [^2]: Model Context Protocol documentation, https://modelcontextprotocol.io/ (retrieved 2026-06-12)</a:t>
             </a:r>
           </a:p>
         </p:txBody>
@@ -4053,7 +4120,7 @@
                   <a:srgbClr val="FFFFFF"/>
                 </a:solidFill>
               </a:rPr>
-              <a:t>  Never rely on "Claude will know not to ask for secrets." A connector must enforce policy in code. The model can be helpful, but the server i</a:t>
+              <a:t>  [^5]: Zod, "Basic usage", https://zod.dev/?id=basic-usage (retrieved 2026-06-12)</a:t>
             </a:r>
           </a:p>
         </p:txBody>
@@ -4061,6 +4128,40 @@
       <p:sp>
         <p:nvSpPr>
           <p:cNvPr id="6" name="TextBox 5"/>
+          <p:cNvSpPr txBox="1"/>
+          <p:nvPr/>
+        </p:nvSpPr>
+        <p:spPr>
+          <a:xfrm>
+            <a:off x="731520" y="3703320"/>
+            <a:ext cx="10698480" cy="960120"/>
+          </a:xfrm>
+          <a:prstGeom prst="rect">
+            <a:avLst/>
+          </a:prstGeom>
+          <a:noFill/>
+        </p:spPr>
+        <p:txBody>
+          <a:bodyPr wrap="square">
+            <a:spAutoFit/>
+          </a:bodyPr>
+          <a:lstStyle/>
+          <a:p>
+            <a:pPr algn="l"/>
+            <a:r>
+              <a:rPr sz="1700" b="0">
+                <a:solidFill>
+                  <a:srgbClr val="FFFFFF"/>
+                </a:solidFill>
+              </a:rPr>
+              <a:t>  [^6]: Node.js, "fs.readdir()", https://nodejs.org/api/fs.html#fsreaddirpath-options-callback (retrieved 2026-06-12)</a:t>
+            </a:r>
+          </a:p>
+        </p:txBody>
+      </p:sp>
+      <p:sp>
+        <p:nvSpPr>
+          <p:cNvPr id="7" name="TextBox 6"/>
           <p:cNvSpPr txBox="1"/>
           <p:nvPr/>
         </p:nvSpPr>
@@ -4126,8 +4227,8 @@
         </p:nvSpPr>
         <p:spPr>
           <a:xfrm>
-            <a:off x="731520" y="411480"/>
-            <a:ext cx="10698480" cy="1005840"/>
+            <a:off x="914400" y="2011680"/>
+            <a:ext cx="10332720" cy="914400"/>
           </a:xfrm>
           <a:prstGeom prst="rect">
             <a:avLst/>
@@ -4140,71 +4241,28 @@
           </a:bodyPr>
           <a:lstStyle/>
           <a:p>
-            <a:pPr algn="l"/>
-            <a:r>
-              <a:rPr sz="2800" b="1">
+            <a:pPr algn="ctr"/>
+            <a:r>
+              <a:rPr sz="3000" b="1">
                 <a:solidFill>
                   <a:srgbClr val="FFFFFF"/>
                 </a:solidFill>
               </a:rPr>
-              <a:t>Controlled errors</a:t>
-            </a:r>
-          </a:p>
-        </p:txBody>
-      </p:sp>
-      <p:sp>
-        <p:nvSpPr>
-          <p:cNvPr id="3" name="Rectangle 2"/>
-          <p:cNvSpPr/>
-          <p:nvPr/>
-        </p:nvSpPr>
-        <p:spPr>
-          <a:xfrm>
-            <a:off x="731520" y="1417320"/>
-            <a:ext cx="10698480" cy="36576"/>
-          </a:xfrm>
-          <a:prstGeom prst="rect">
-            <a:avLst/>
-          </a:prstGeom>
-          <a:solidFill>
-            <a:srgbClr val="A1A1AA"/>
-          </a:solidFill>
-          <a:ln>
-            <a:noFill/>
-          </a:ln>
-        </p:spPr>
-        <p:style>
-          <a:lnRef idx="1">
-            <a:schemeClr val="accent1"/>
-          </a:lnRef>
-          <a:fillRef idx="3">
-            <a:schemeClr val="accent1"/>
-          </a:fillRef>
-          <a:effectRef idx="2">
-            <a:schemeClr val="accent1"/>
-          </a:effectRef>
-          <a:fontRef idx="minor">
-            <a:schemeClr val="lt1"/>
-          </a:fontRef>
-        </p:style>
-        <p:txBody>
-          <a:bodyPr rtlCol="0" anchor="ctr"/>
-          <a:lstStyle/>
-          <a:p>
-            <a:pPr algn="ctr"/>
-          </a:p>
-        </p:txBody>
-      </p:sp>
-      <p:sp>
-        <p:nvSpPr>
-          <p:cNvPr id="4" name="TextBox 3"/>
+              <a:t>Read the full article</a:t>
+            </a:r>
+          </a:p>
+        </p:txBody>
+      </p:sp>
+      <p:sp>
+        <p:nvSpPr>
+          <p:cNvPr id="3" name="TextBox 2"/>
           <p:cNvSpPr txBox="1"/>
           <p:nvPr/>
         </p:nvSpPr>
         <p:spPr>
           <a:xfrm>
-            <a:off x="731520" y="1600200"/>
-            <a:ext cx="10698480" cy="960120"/>
+            <a:off x="914400" y="3200400"/>
+            <a:ext cx="10332720" cy="822960"/>
           </a:xfrm>
           <a:prstGeom prst="rect">
             <a:avLst/>
@@ -4217,28 +4275,28 @@
           </a:bodyPr>
           <a:lstStyle/>
           <a:p>
-            <a:pPr algn="l"/>
-            <a:r>
-              <a:rPr sz="1700" b="0">
-                <a:solidFill>
-                  <a:srgbClr val="FFFFFF"/>
+            <a:pPr algn="ctr"/>
+            <a:r>
+              <a:rPr sz="3600" b="1">
+                <a:solidFill>
+                  <a:srgbClr val="A1A1AA"/>
                 </a:solidFill>
               </a:rPr>
-              <a:t>  Errors are part of the user experience. A stack trace is useful to an attacker and confusing to a learner. A controlled error says what fail</a:t>
-            </a:r>
-          </a:p>
-        </p:txBody>
-      </p:sp>
-      <p:sp>
-        <p:nvSpPr>
-          <p:cNvPr id="5" name="TextBox 4"/>
+              <a:t>academy.kspl.tech</a:t>
+            </a:r>
+          </a:p>
+        </p:txBody>
+      </p:sp>
+      <p:sp>
+        <p:nvSpPr>
+          <p:cNvPr id="4" name="TextBox 3"/>
           <p:cNvSpPr txBox="1"/>
           <p:nvPr/>
         </p:nvSpPr>
         <p:spPr>
           <a:xfrm>
-            <a:off x="731520" y="2651760"/>
-            <a:ext cx="10698480" cy="960120"/>
+            <a:off x="914400" y="6263640"/>
+            <a:ext cx="10332720" cy="365760"/>
           </a:xfrm>
           <a:prstGeom prst="rect">
             <a:avLst/>
@@ -4251,244 +4309,14 @@
           </a:bodyPr>
           <a:lstStyle/>
           <a:p>
-            <a:pPr algn="l"/>
-            <a:r>
-              <a:rPr sz="1700" b="0">
-                <a:solidFill>
-                  <a:srgbClr val="FFFFFF"/>
+            <a:pPr algn="ctr"/>
+            <a:r>
+              <a:rPr sz="1200" b="0">
+                <a:solidFill>
+                  <a:srgbClr val="A1A1AA"/>
                 </a:solidFill>
               </a:rPr>
-              <a:t>  For this chapter, use three predictable errors:</a:t>
-            </a:r>
-          </a:p>
-        </p:txBody>
-      </p:sp>
-      <p:sp>
-        <p:nvSpPr>
-          <p:cNvPr id="6" name="TextBox 5"/>
-          <p:cNvSpPr txBox="1"/>
-          <p:nvPr/>
-        </p:nvSpPr>
-        <p:spPr>
-          <a:xfrm>
-            <a:off x="731520" y="3703320"/>
-            <a:ext cx="10698480" cy="960120"/>
-          </a:xfrm>
-          <a:prstGeom prst="rect">
-            <a:avLst/>
-          </a:prstGeom>
-          <a:noFill/>
-        </p:spPr>
-        <p:txBody>
-          <a:bodyPr wrap="square">
-            <a:spAutoFit/>
-          </a:bodyPr>
-          <a:lstStyle/>
-          <a:p>
-            <a:pPr algn="l"/>
-            <a:r>
-              <a:rPr sz="1700" b="0">
-                <a:solidFill>
-                  <a:srgbClr val="FFFFFF"/>
-                </a:solidFill>
-              </a:rPr>
-              <a:t>  Unknown root label.</a:t>
-            </a:r>
-          </a:p>
-        </p:txBody>
-      </p:sp>
-      <p:sp>
-        <p:nvSpPr>
-          <p:cNvPr id="7" name="TextBox 6"/>
-          <p:cNvSpPr txBox="1"/>
-          <p:nvPr/>
-        </p:nvSpPr>
-        <p:spPr>
-          <a:xfrm>
-            <a:off x="731520" y="4754880"/>
-            <a:ext cx="10698480" cy="960120"/>
-          </a:xfrm>
-          <a:prstGeom prst="rect">
-            <a:avLst/>
-          </a:prstGeom>
-          <a:noFill/>
-        </p:spPr>
-        <p:txBody>
-          <a:bodyPr wrap="square">
-            <a:spAutoFit/>
-          </a:bodyPr>
-          <a:lstStyle/>
-          <a:p>
-            <a:pPr algn="l"/>
-            <a:r>
-              <a:rPr sz="1700" b="0">
-                <a:solidFill>
-                  <a:srgbClr val="FFFFFF"/>
-                </a:solidFill>
-              </a:rPr>
-              <a:t>  Path escapes approved root.</a:t>
-            </a:r>
-          </a:p>
-        </p:txBody>
-      </p:sp>
-      <p:sp>
-        <p:nvSpPr>
-          <p:cNvPr id="8" name="TextBox 7"/>
-          <p:cNvSpPr txBox="1"/>
-          <p:nvPr/>
-        </p:nvSpPr>
-        <p:spPr>
-          <a:xfrm>
-            <a:off x="731520" y="6263640"/>
-            <a:ext cx="10698480" cy="365760"/>
-          </a:xfrm>
-          <a:prstGeom prst="rect">
-            <a:avLst/>
-          </a:prstGeom>
-          <a:noFill/>
-        </p:spPr>
-        <p:txBody>
-          <a:bodyPr wrap="square">
-            <a:spAutoFit/>
-          </a:bodyPr>
-          <a:lstStyle/>
-          <a:p>
-            <a:pPr algn="l"/>
-            <a:r>
-              <a:rPr sz="1000" b="0">
-                <a:solidFill>
-                  <a:srgbClr val="A1A1AA"/>
-                </a:solidFill>
-              </a:rPr>
-              <a:t>academy.kspl.tech | Koenig AI Academy</a:t>
-            </a:r>
-          </a:p>
-        </p:txBody>
-      </p:sp>
-    </p:spTree>
-  </p:cSld>
-  <p:clrMapOvr>
-    <a:masterClrMapping/>
-  </p:clrMapOvr>
-</p:sld>
-</file>
-
-<file path=ppt/slides/slide7.xml><?xml version="1.0" encoding="utf-8"?>
-<p:sld xmlns:a="http://schemas.openxmlformats.org/drawingml/2006/main" xmlns:p="http://schemas.openxmlformats.org/presentationml/2006/main" xmlns:r="http://schemas.openxmlformats.org/officeDocument/2006/relationships">
-  <p:cSld>
-    <p:bg>
-      <p:bgPr>
-        <a:solidFill>
-          <a:srgbClr val="18181B"/>
-        </a:solidFill>
-        <a:effectLst/>
-      </p:bgPr>
-    </p:bg>
-    <p:spTree>
-      <p:nvGrpSpPr>
-        <p:cNvPr id="1" name=""/>
-        <p:cNvGrpSpPr/>
-        <p:nvPr/>
-      </p:nvGrpSpPr>
-      <p:grpSpPr/>
-      <p:sp>
-        <p:nvSpPr>
-          <p:cNvPr id="2" name="TextBox 1"/>
-          <p:cNvSpPr txBox="1"/>
-          <p:nvPr/>
-        </p:nvSpPr>
-        <p:spPr>
-          <a:xfrm>
-            <a:off x="914400" y="2011680"/>
-            <a:ext cx="10332720" cy="914400"/>
-          </a:xfrm>
-          <a:prstGeom prst="rect">
-            <a:avLst/>
-          </a:prstGeom>
-          <a:noFill/>
-        </p:spPr>
-        <p:txBody>
-          <a:bodyPr wrap="square">
-            <a:spAutoFit/>
-          </a:bodyPr>
-          <a:lstStyle/>
-          <a:p>
-            <a:pPr algn="ctr"/>
-            <a:r>
-              <a:rPr sz="3400" b="1">
-                <a:solidFill>
-                  <a:srgbClr val="FFFFFF"/>
-                </a:solidFill>
-              </a:rPr>
-              <a:t>Try it next</a:t>
-            </a:r>
-          </a:p>
-        </p:txBody>
-      </p:sp>
-      <p:sp>
-        <p:nvSpPr>
-          <p:cNvPr id="3" name="TextBox 2"/>
-          <p:cNvSpPr txBox="1"/>
-          <p:nvPr/>
-        </p:nvSpPr>
-        <p:spPr>
-          <a:xfrm>
-            <a:off x="914400" y="3200400"/>
-            <a:ext cx="10332720" cy="1097280"/>
-          </a:xfrm>
-          <a:prstGeom prst="rect">
-            <a:avLst/>
-          </a:prstGeom>
-          <a:noFill/>
-        </p:spPr>
-        <p:txBody>
-          <a:bodyPr wrap="square">
-            <a:spAutoFit/>
-          </a:bodyPr>
-          <a:lstStyle/>
-          <a:p>
-            <a:pPr algn="ctr"/>
-            <a:r>
-              <a:rPr sz="2000" b="0">
-                <a:solidFill>
-                  <a:srgbClr val="A1A1AA"/>
-                </a:solidFill>
-              </a:rPr>
-              <a:t>Deploy a gateway with RBAC, rate limits, and JSONL auditing</a:t>
-            </a:r>
-          </a:p>
-        </p:txBody>
-      </p:sp>
-      <p:sp>
-        <p:nvSpPr>
-          <p:cNvPr id="4" name="TextBox 3"/>
-          <p:cNvSpPr txBox="1"/>
-          <p:nvPr/>
-        </p:nvSpPr>
-        <p:spPr>
-          <a:xfrm>
-            <a:off x="731520" y="6263640"/>
-            <a:ext cx="10698480" cy="365760"/>
-          </a:xfrm>
-          <a:prstGeom prst="rect">
-            <a:avLst/>
-          </a:prstGeom>
-          <a:noFill/>
-        </p:spPr>
-        <p:txBody>
-          <a:bodyPr wrap="square">
-            <a:spAutoFit/>
-          </a:bodyPr>
-          <a:lstStyle/>
-          <a:p>
-            <a:pPr algn="l"/>
-            <a:r>
-              <a:rPr sz="1000" b="0">
-                <a:solidFill>
-                  <a:srgbClr val="A1A1AA"/>
-                </a:solidFill>
-              </a:rPr>
-              <a:t>academy.kspl.tech | Koenig AI Academy</a:t>
+              <a:t>Koenig AI Academy</a:t>
             </a:r>
           </a:p>
         </p:txBody>

</xml_diff>

<commit_message>
fix(slides): KOEA-8290 — address all 3 G0 blockers in claude-tool-use-from-zero ch03-slides.pptx
- Slide 2: complete 'What the server will do' with 6 bullets describing list_project_files tool (root restriction, path sanitisation, JSON response, stdio transport)
- Slide 5: replace raw footnote citations ([^2],[^5],[^6]) with 5 forward-looking Chapter 4 bullets (resources, binary content, multi-tool servers, advanced Zod)
- Slide 6: change blog CTA 'Read the full article' to course CTA 'Try it next · Continue to Chapter 4'
</commit_message>
<xml_diff>
--- a/vault/courses/claude-tool-use-from-zero/ch03-slides.pptx
+++ b/vault/courses/claude-tool-use-from-zero/ch03-slides.pptx
@@ -3294,14 +3294,63 @@
           </a:bodyPr>
           <a:lstStyle/>
           <a:p>
-            <a:pPr algn="l"/>
             <a:r>
               <a:rPr sz="1700" b="0">
                 <a:solidFill>
                   <a:srgbClr val="FFFFFF"/>
                 </a:solidFill>
               </a:rPr>
-              <a:t>  The server exposes one tool-use capability:</a:t>
+              <a:t>  The server exposes one tool-use capability: list_project_files</a:t>
+            </a:r>
+          </a:p>
+          <a:p>
+            <a:r>
+              <a:rPr sz="1700" b="0">
+                <a:solidFill>
+                  <a:srgbClr val="FFFFFF"/>
+                </a:solidFill>
+              </a:rPr>
+              <a:t>  Lists files under a pre-approved root directory — arbitrary paths are blocked at the schema level</a:t>
+            </a:r>
+          </a:p>
+          <a:p>
+            <a:r>
+              <a:rPr sz="1700" b="0">
+                <a:solidFill>
+                  <a:srgbClr val="FFFFFF"/>
+                </a:solidFill>
+              </a:rPr>
+              <a:t>  Enforces path sanitisation in server code — ../ traversal is rejected before filesystem access</a:t>
+            </a:r>
+          </a:p>
+          <a:p>
+            <a:r>
+              <a:rPr sz="1700" b="0">
+                <a:solidFill>
+                  <a:srgbClr val="FFFFFF"/>
+                </a:solidFill>
+              </a:rPr>
+              <a:t>  Returns a JSON array of file names and types, not file contents</a:t>
+            </a:r>
+          </a:p>
+          <a:p>
+            <a:r>
+              <a:rPr sz="1700" b="0">
+                <a:solidFill>
+                  <a:srgbClr val="FFFFFF"/>
+                </a:solidFill>
+              </a:rPr>
+              <a:t>  Communicates over stdio transport, connecting to Claude Code as a local MCP server</a:t>
+            </a:r>
+          </a:p>
+          <a:p>
+            <a:r>
+              <a:rPr sz="1700" b="0">
+                <a:solidFill>
+                  <a:srgbClr val="FFFFFF"/>
+                </a:solidFill>
+              </a:rPr>
+              <a:t>  Root directories are fixed via a root_label enum — the model cannot request arbitrary paths</a:t>
             </a:r>
           </a:p>
         </p:txBody>
@@ -4079,14 +4128,53 @@
           </a:bodyPr>
           <a:lstStyle/>
           <a:p>
-            <a:pPr algn="l"/>
             <a:r>
               <a:rPr sz="1700" b="0">
                 <a:solidFill>
                   <a:srgbClr val="FFFFFF"/>
                 </a:solidFill>
               </a:rPr>
-              <a:t>  [^2]: Model Context Protocol documentation, https://modelcontextprotocol.io/ (retrieved 2026-06-12)</a:t>
+              <a:t>  Chapter 4: expand the server from callable tools to MCP resources</a:t>
+            </a:r>
+          </a:p>
+          <a:p>
+            <a:r>
+              <a:rPr sz="1700" b="0">
+                <a:solidFill>
+                  <a:srgbClr val="FFFFFF"/>
+                </a:solidFill>
+              </a:rPr>
+              <a:t>  Return binary content and stream data from tool responses</a:t>
+            </a:r>
+          </a:p>
+          <a:p>
+            <a:r>
+              <a:rPr sz="1700" b="0">
+                <a:solidFill>
+                  <a:srgbClr val="FFFFFF"/>
+                </a:solidFill>
+              </a:rPr>
+              <a:t>  Build multi-tool MCP servers that share validated state</a:t>
+            </a:r>
+          </a:p>
+          <a:p>
+            <a:r>
+              <a:rPr sz="1700" b="0">
+                <a:solidFill>
+                  <a:srgbClr val="FFFFFF"/>
+                </a:solidFill>
+              </a:rPr>
+              <a:t>  Connect resource reads to tool actions in a single server</a:t>
+            </a:r>
+          </a:p>
+          <a:p>
+            <a:r>
+              <a:rPr sz="1700" b="0">
+                <a:solidFill>
+                  <a:srgbClr val="FFFFFF"/>
+                </a:solidFill>
+              </a:rPr>
+              <a:t>  Advanced Zod schemas: optional fields, unions, and nested objects</a:t>
             </a:r>
           </a:p>
         </p:txBody>
@@ -4113,14 +4201,13 @@
           </a:bodyPr>
           <a:lstStyle/>
           <a:p>
-            <a:pPr algn="l"/>
             <a:r>
               <a:rPr sz="1700" b="0">
                 <a:solidFill>
                   <a:srgbClr val="FFFFFF"/>
                 </a:solidFill>
               </a:rPr>
-              <a:t>  [^5]: Zod, "Basic usage", https://zod.dev/?id=basic-usage (retrieved 2026-06-12)</a:t>
+              <a:t/>
             </a:r>
           </a:p>
         </p:txBody>
@@ -4147,14 +4234,13 @@
           </a:bodyPr>
           <a:lstStyle/>
           <a:p>
-            <a:pPr algn="l"/>
             <a:r>
               <a:rPr sz="1700" b="0">
                 <a:solidFill>
                   <a:srgbClr val="FFFFFF"/>
                 </a:solidFill>
               </a:rPr>
-              <a:t>  [^6]: Node.js, "fs.readdir()", https://nodejs.org/api/fs.html#fsreaddirpath-options-callback (retrieved 2026-06-12)</a:t>
+              <a:t/>
             </a:r>
           </a:p>
         </p:txBody>
@@ -4241,14 +4327,13 @@
           </a:bodyPr>
           <a:lstStyle/>
           <a:p>
-            <a:pPr algn="ctr"/>
             <a:r>
               <a:rPr sz="3000" b="1">
                 <a:solidFill>
                   <a:srgbClr val="FFFFFF"/>
                 </a:solidFill>
               </a:rPr>
-              <a:t>Read the full article</a:t>
+              <a:t>Try it next · Continue to Chapter 4</a:t>
             </a:r>
           </a:p>
         </p:txBody>

</xml_diff>